<commit_message>
Fix method/protocol figure layout and package the paper figures
fig_method_protocol: the last pipeline box ran off the right edge, the
key label overflowed its box and was crossed by an arrow, the seal arrow
struck through a caption, and the external-corpus text overflowed. Also
uses the paper's terms (IoM-GRP, M groups of q, embedding in R^d).

Adds figures/README.txt (one plain explanation per figure) and a zip of
the ten paper figures in PNG and PDF, named by paper figure number. The
slide deck is rebuilt with the fixed figure.

Co-Authored-By: Claude Opus 5.5 <noreply@anthropic.com>
Claude-Session: https://claude.ai/code/session_015qTqY1Nv8brQ5r62DVZnUT
</commit_message>
<xml_diff>
--- a/experiments/attackaware_polyiom/paper/deck/AttackAware_PolyIoM_paper.pptx
+++ b/experiments/attackaware_polyiom/paper/deck/AttackAware_PolyIoM_paper.pptx
@@ -130,43 +130,43 @@
   <p:extLst>
     <p:ext uri="{521415D9-36F7-43E2-AB2F-B90AF26B5E84}">
       <p14:sectionLst xmlns:p14="http://schemas.microsoft.com/office/powerpoint/2010/main">
-        <p14:section name="Title" id="{477f3cda-6264-dfb0-af3a-bd51164bb8e2}">
+        <p14:section name="Title" id="{1faf12e0-7132-38ff-c041-19da1b61021b}">
           <p14:sldIdLst>
             <p14:sldId id="256"/>
           </p14:sldIdLst>
         </p14:section>
-        <p14:section name="Abstract" id="{39230ce6-2235-ea09-78dd-4bcf1a3f0c36}">
+        <p14:section name="Abstract" id="{0d3e4b59-bd8c-ad37-e9b7-217956dafb09}">
           <p14:sldIdLst>
             <p14:sldId id="257"/>
           </p14:sldIdLst>
         </p14:section>
-        <p14:section name="1 Introduction" id="{c88aa067-0ca8-78b5-589f-0765247daba5}">
+        <p14:section name="1 Introduction" id="{d9802798-a777-78db-da05-5ce1a549e545}">
           <p14:sldIdLst>
             <p14:sldId id="258"/>
             <p14:sldId id="259"/>
             <p14:sldId id="260"/>
           </p14:sldIdLst>
         </p14:section>
-        <p14:section name="2 Background and related work" id="{b2d58014-0846-7c13-26cb-0f0b17b161c9}">
+        <p14:section name="2 Background and related work" id="{1753990e-e7d9-411e-4954-6f4d99e0d006}">
           <p14:sldIdLst>
             <p14:sldId id="261"/>
           </p14:sldIdLst>
         </p14:section>
-        <p14:section name="3 Method" id="{4a9bcd04-70e6-287e-cc5b-3cada199517a}">
+        <p14:section name="3 Method" id="{29ebe937-971b-b8b9-0e73-c9cad2fa9f04}">
           <p14:sldIdLst>
             <p14:sldId id="262"/>
             <p14:sldId id="263"/>
             <p14:sldId id="264"/>
           </p14:sldIdLst>
         </p14:section>
-        <p14:section name="4 Experimental protocol" id="{c63c13e0-3d0f-a71a-768f-92f8417d9ef7}">
+        <p14:section name="4 Experimental protocol" id="{4bcaf1d7-4630-146a-2b9b-4cfd5802a2aa}">
           <p14:sldIdLst>
             <p14:sldId id="265"/>
             <p14:sldId id="266"/>
             <p14:sldId id="267"/>
           </p14:sldIdLst>
         </p14:section>
-        <p14:section name="5 Results" id="{9df16c06-b792-ed27-6c35-4d63e4119b86}">
+        <p14:section name="5 Results" id="{5bdb25c3-72c9-9607-922e-2a90b381bc13}">
           <p14:sldIdLst>
             <p14:sldId id="268"/>
             <p14:sldId id="269"/>
@@ -177,23 +177,23 @@
             <p14:sldId id="274"/>
           </p14:sldIdLst>
         </p14:section>
-        <p14:section name="6 Discussion" id="{ce81f9a5-524d-ed8c-6507-404fc0a52353}">
+        <p14:section name="6 Discussion" id="{b0c05726-d369-d102-3793-21118a967f25}">
           <p14:sldIdLst>
             <p14:sldId id="275"/>
             <p14:sldId id="276"/>
           </p14:sldIdLst>
         </p14:section>
-        <p14:section name="7 Limitations" id="{40d465bc-2bfb-a7d4-9155-ba7fc0620316}">
+        <p14:section name="7 Limitations" id="{72f4faa2-4298-b776-06cc-104591508518}">
           <p14:sldIdLst>
             <p14:sldId id="277"/>
           </p14:sldIdLst>
         </p14:section>
-        <p14:section name="8 Conclusion" id="{127c8899-bf14-7630-c13f-36bb7c431156}">
+        <p14:section name="8 Conclusion" id="{d6489127-3038-74fd-0837-daed65515c8b}">
           <p14:sldIdLst>
             <p14:sldId id="278"/>
           </p14:sldIdLst>
         </p14:section>
-        <p14:section name="Declarations" id="{56602c87-0b08-b494-5eb1-363f6055514c}">
+        <p14:section name="Declarations" id="{4e4cc313-4fc0-551a-657d-50ac8a5678d4}">
           <p14:sldIdLst>
             <p14:sldId id="279"/>
           </p14:sldIdLst>

</xml_diff>